<commit_message>
docs: update presentation with student names, supervisor, center alignment, and completed conclusions
</commit_message>
<xml_diff>
--- a/TrustCheck_BIT_Mesra_Presentation.pptx
+++ b/TrustCheck_BIT_Mesra_Presentation.pptx
@@ -3197,8 +3197,8 @@
         </p:nvSpPr>
         <p:spPr>
           <a:xfrm>
-            <a:off x="5760720" y="4206240"/>
-            <a:ext cx="5760720" cy="2377440"/>
+            <a:off x="5760720" y="4114800"/>
+            <a:ext cx="5760720" cy="2468880"/>
           </a:xfrm>
           <a:prstGeom prst="rect">
             <a:avLst/>
@@ -3226,72 +3226,56 @@
           <a:p>
             <a:pPr>
               <a:spcBef>
+                <a:spcPts val="300"/>
+              </a:spcBef>
+              <a:defRPr sz="1400" b="1">
+                <a:solidFill>
+                  <a:srgbClr val="002060"/>
+                </a:solidFill>
+                <a:latin typeface="Franklin Gothic Book"/>
+              </a:defRPr>
+            </a:pPr>
+            <a:r>
+              <a:t>• Muskan Jain  [BCA/25014/14]</a:t>
+            </a:r>
+          </a:p>
+          <a:p>
+            <a:pPr>
+              <a:spcBef>
+                <a:spcPts val="300"/>
+              </a:spcBef>
+              <a:defRPr sz="1400" b="1">
+                <a:solidFill>
+                  <a:srgbClr val="002060"/>
+                </a:solidFill>
+                <a:latin typeface="Franklin Gothic Book"/>
+              </a:defRPr>
+            </a:pPr>
+            <a:r>
+              <a:t>• Disha Kodasia  [BCA/25006/24]</a:t>
+            </a:r>
+          </a:p>
+          <a:p>
+            <a:pPr>
+              <a:spcBef>
+                <a:spcPts val="800"/>
+              </a:spcBef>
+              <a:defRPr sz="1300">
+                <a:solidFill>
+                  <a:srgbClr val="5A6978"/>
+                </a:solidFill>
+                <a:latin typeface="Franklin Gothic Book"/>
+              </a:defRPr>
+            </a:pPr>
+            <a:r>
+              <a:t>Under the Supervision of:</a:t>
+            </a:r>
+          </a:p>
+          <a:p>
+            <a:pPr>
+              <a:spcBef>
                 <a:spcPts val="200"/>
               </a:spcBef>
-              <a:defRPr sz="1400" b="1">
-                <a:solidFill>
-                  <a:srgbClr val="002060"/>
-                </a:solidFill>
-                <a:latin typeface="Franklin Gothic Book"/>
-              </a:defRPr>
-            </a:pPr>
-            <a:r>
-              <a:t>• Muskan Papdiwal  [Roll No: [BCA/XXXXX/XX]]</a:t>
-            </a:r>
-          </a:p>
-          <a:p>
-            <a:pPr>
-              <a:spcBef>
-                <a:spcPts val="200"/>
-              </a:spcBef>
-              <a:defRPr sz="1400" b="1">
-                <a:solidFill>
-                  <a:srgbClr val="002060"/>
-                </a:solidFill>
-                <a:latin typeface="Franklin Gothic Book"/>
-              </a:defRPr>
-            </a:pPr>
-            <a:r>
-              <a:t>• Team Member 2  [Roll No: [BCA/XXXXX/XX]]</a:t>
-            </a:r>
-          </a:p>
-          <a:p>
-            <a:pPr>
-              <a:spcBef>
-                <a:spcPts val="200"/>
-              </a:spcBef>
-              <a:defRPr sz="1400" b="1">
-                <a:solidFill>
-                  <a:srgbClr val="002060"/>
-                </a:solidFill>
-                <a:latin typeface="Franklin Gothic Book"/>
-              </a:defRPr>
-            </a:pPr>
-            <a:r>
-              <a:t>• Team Member 3  [Roll No: [BCA/XXXXX/XX]]</a:t>
-            </a:r>
-          </a:p>
-          <a:p>
-            <a:pPr>
-              <a:spcBef>
-                <a:spcPts val="600"/>
-              </a:spcBef>
-              <a:defRPr sz="1300">
-                <a:solidFill>
-                  <a:srgbClr val="5A6978"/>
-                </a:solidFill>
-                <a:latin typeface="Franklin Gothic Book"/>
-              </a:defRPr>
-            </a:pPr>
-            <a:r>
-              <a:t>Under the Supervision of:</a:t>
-            </a:r>
-          </a:p>
-          <a:p>
-            <a:pPr>
-              <a:spcBef>
-                <a:spcPts val="100"/>
-              </a:spcBef>
               <a:defRPr sz="1600" b="1">
                 <a:solidFill>
                   <a:srgbClr val="C00000"/>
@@ -3300,7 +3284,7 @@
               </a:defRPr>
             </a:pPr>
             <a:r>
-              <a:t>Dr. / Mr. [Name of Guide]</a:t>
+              <a:t>Mr. Santosh Kumar Sharma</a:t>
             </a:r>
           </a:p>
           <a:p>
@@ -3428,7 +3412,7 @@
           <a:lstStyle/>
           <a:p>
             <a:pPr>
-              <a:defRPr sz="1200" b="1">
+              <a:defRPr sz="1300" b="1">
                 <a:solidFill>
                   <a:srgbClr val="5A6978"/>
                 </a:solidFill>
@@ -3442,86 +3426,70 @@
           <a:p>
             <a:pPr>
               <a:spcBef>
+                <a:spcPts val="300"/>
+              </a:spcBef>
+              <a:defRPr sz="1500" b="1">
+                <a:solidFill>
+                  <a:srgbClr val="002060"/>
+                </a:solidFill>
+                <a:latin typeface="Franklin Gothic Demi"/>
+              </a:defRPr>
+            </a:pPr>
+            <a:r>
+              <a:t>• Muskan Jain  [BCA/25014/14]</a:t>
+            </a:r>
+          </a:p>
+          <a:p>
+            <a:pPr>
+              <a:spcBef>
+                <a:spcPts val="300"/>
+              </a:spcBef>
+              <a:defRPr sz="1500" b="1">
+                <a:solidFill>
+                  <a:srgbClr val="002060"/>
+                </a:solidFill>
+                <a:latin typeface="Franklin Gothic Demi"/>
+              </a:defRPr>
+            </a:pPr>
+            <a:r>
+              <a:t>• Disha Kodasia  [BCA/25006/24]</a:t>
+            </a:r>
+          </a:p>
+          <a:p>
+            <a:pPr>
+              <a:spcBef>
+                <a:spcPts val="800"/>
+              </a:spcBef>
+              <a:defRPr sz="1300">
+                <a:solidFill>
+                  <a:srgbClr val="5A6978"/>
+                </a:solidFill>
+                <a:latin typeface="Franklin Gothic Book"/>
+              </a:defRPr>
+            </a:pPr>
+            <a:r>
+              <a:t>Under the Supervision of:</a:t>
+            </a:r>
+          </a:p>
+          <a:p>
+            <a:pPr>
+              <a:spcBef>
                 <a:spcPts val="200"/>
               </a:spcBef>
-              <a:defRPr sz="1400" b="1">
-                <a:solidFill>
-                  <a:srgbClr val="002060"/>
+              <a:defRPr sz="1600" b="1">
+                <a:solidFill>
+                  <a:srgbClr val="C00000"/>
                 </a:solidFill>
                 <a:latin typeface="Franklin Gothic Demi"/>
               </a:defRPr>
             </a:pPr>
             <a:r>
-              <a:t>• Muskan Papdiwal  [Roll No: [BCA/XXXXX/XX]]</a:t>
+              <a:t>Mr. Santosh Kumar Sharma</a:t>
             </a:r>
           </a:p>
           <a:p>
             <a:pPr>
-              <a:spcBef>
-                <a:spcPts val="200"/>
-              </a:spcBef>
-              <a:defRPr sz="1400" b="1">
-                <a:solidFill>
-                  <a:srgbClr val="002060"/>
-                </a:solidFill>
-                <a:latin typeface="Franklin Gothic Demi"/>
-              </a:defRPr>
-            </a:pPr>
-            <a:r>
-              <a:t>• Team Member 2  [Roll No: [BCA/XXXXX/XX]]</a:t>
-            </a:r>
-          </a:p>
-          <a:p>
-            <a:pPr>
-              <a:spcBef>
-                <a:spcPts val="200"/>
-              </a:spcBef>
-              <a:defRPr sz="1400" b="1">
-                <a:solidFill>
-                  <a:srgbClr val="002060"/>
-                </a:solidFill>
-                <a:latin typeface="Franklin Gothic Demi"/>
-              </a:defRPr>
-            </a:pPr>
-            <a:r>
-              <a:t>• Team Member 3  [Roll No: [BCA/XXXXX/XX]]</a:t>
-            </a:r>
-          </a:p>
-          <a:p>
-            <a:pPr>
-              <a:spcBef>
-                <a:spcPts val="600"/>
-              </a:spcBef>
-              <a:defRPr sz="1200">
-                <a:solidFill>
-                  <a:srgbClr val="5A6978"/>
-                </a:solidFill>
-                <a:latin typeface="Franklin Gothic Book"/>
-              </a:defRPr>
-            </a:pPr>
-            <a:r>
-              <a:t>Under the Supervision of:</a:t>
-            </a:r>
-          </a:p>
-          <a:p>
-            <a:pPr>
-              <a:spcBef>
-                <a:spcPts val="200"/>
-              </a:spcBef>
-              <a:defRPr sz="1600" b="1">
-                <a:solidFill>
-                  <a:srgbClr val="C00000"/>
-                </a:solidFill>
-                <a:latin typeface="Franklin Gothic Demi"/>
-              </a:defRPr>
-            </a:pPr>
-            <a:r>
-              <a:t>Dr. / Mr. [Name of Guide]</a:t>
-            </a:r>
-          </a:p>
-          <a:p>
-            <a:pPr>
-              <a:defRPr sz="1200">
+              <a:defRPr sz="1300">
                 <a:solidFill>
                   <a:srgbClr val="18202F"/>
                 </a:solidFill>
@@ -3610,31 +3578,47 @@
               </a:defRPr>
             </a:pPr>
             <a:r>
-              <a:t>QUESTIONS &amp; DISCUSSION</a:t>
+              <a:t>PROJECT LINKS &amp; RESOURCES</a:t>
             </a:r>
           </a:p>
           <a:p>
             <a:pPr>
               <a:spcBef>
-                <a:spcPts val="400"/>
-              </a:spcBef>
-              <a:defRPr sz="1400">
-                <a:solidFill>
-                  <a:srgbClr val="18202F"/>
+                <a:spcPts val="800"/>
+              </a:spcBef>
+              <a:defRPr sz="1300" b="1">
+                <a:solidFill>
+                  <a:srgbClr val="002060"/>
+                </a:solidFill>
+                <a:latin typeface="Franklin Gothic Demi"/>
+              </a:defRPr>
+            </a:pPr>
+            <a:r>
+              <a:t>• Live Web Application:</a:t>
+            </a:r>
+          </a:p>
+          <a:p>
+            <a:pPr>
+              <a:spcBef>
+                <a:spcPts val="100"/>
+              </a:spcBef>
+              <a:defRPr sz="1150">
+                <a:solidFill>
+                  <a:srgbClr val="5A6978"/>
                 </a:solidFill>
                 <a:latin typeface="Franklin Gothic Book"/>
               </a:defRPr>
             </a:pPr>
             <a:r>
-              <a:t>Thank you! We welcome any questions and feedback.</a:t>
+              <a:t>   https://trust-check-rouge.vercel.app/</a:t>
             </a:r>
           </a:p>
           <a:p>
             <a:pPr>
               <a:spcBef>
-                <a:spcPts val="600"/>
-              </a:spcBef>
-              <a:defRPr sz="1200" b="1">
+                <a:spcPts val="800"/>
+              </a:spcBef>
+              <a:defRPr sz="1300" b="1">
                 <a:solidFill>
                   <a:srgbClr val="002060"/>
                 </a:solidFill>
@@ -3642,7 +3626,7 @@
               </a:defRPr>
             </a:pPr>
             <a:r>
-              <a:t>• Live Web App:</a:t>
+              <a:t>• Real-Time Dashboard:</a:t>
             </a:r>
           </a:p>
           <a:p>
@@ -3650,7 +3634,7 @@
               <a:spcBef>
                 <a:spcPts val="100"/>
               </a:spcBef>
-              <a:defRPr sz="1100">
+              <a:defRPr sz="1150">
                 <a:solidFill>
                   <a:srgbClr val="5A6978"/>
                 </a:solidFill>
@@ -3658,15 +3642,15 @@
               </a:defRPr>
             </a:pPr>
             <a:r>
-              <a:t>   https://trust-check-rouge.vercel.app/</a:t>
+              <a:t>   https://trust-check-rouge.vercel.app/dashboard</a:t>
             </a:r>
           </a:p>
           <a:p>
             <a:pPr>
               <a:spcBef>
-                <a:spcPts val="600"/>
-              </a:spcBef>
-              <a:defRPr sz="1200" b="1">
+                <a:spcPts val="800"/>
+              </a:spcBef>
+              <a:defRPr sz="1300" b="1">
                 <a:solidFill>
                   <a:srgbClr val="002060"/>
                 </a:solidFill>
@@ -3674,7 +3658,7 @@
               </a:defRPr>
             </a:pPr>
             <a:r>
-              <a:t>• Live Dashboard:</a:t>
+              <a:t>• Source Code Repository:</a:t>
             </a:r>
           </a:p>
           <a:p>
@@ -3682,39 +3666,7 @@
               <a:spcBef>
                 <a:spcPts val="100"/>
               </a:spcBef>
-              <a:defRPr sz="1100">
-                <a:solidFill>
-                  <a:srgbClr val="5A6978"/>
-                </a:solidFill>
-                <a:latin typeface="Franklin Gothic Book"/>
-              </a:defRPr>
-            </a:pPr>
-            <a:r>
-              <a:t>   https://trust-check-rouge.vercel.app/dashboard</a:t>
-            </a:r>
-          </a:p>
-          <a:p>
-            <a:pPr>
-              <a:spcBef>
-                <a:spcPts val="600"/>
-              </a:spcBef>
-              <a:defRPr sz="1200" b="1">
-                <a:solidFill>
-                  <a:srgbClr val="002060"/>
-                </a:solidFill>
-                <a:latin typeface="Franklin Gothic Demi"/>
-              </a:defRPr>
-            </a:pPr>
-            <a:r>
-              <a:t>• GitHub Repository:</a:t>
-            </a:r>
-          </a:p>
-          <a:p>
-            <a:pPr>
-              <a:spcBef>
-                <a:spcPts val="100"/>
-              </a:spcBef>
-              <a:defRPr sz="1100">
+              <a:defRPr sz="1150">
                 <a:solidFill>
                   <a:srgbClr val="5A6978"/>
                 </a:solidFill>
@@ -4330,7 +4282,7 @@
               </a:defRPr>
             </a:pPr>
             <a:r>
-              <a:t>06. Conclusions &amp; Next Steps</a:t>
+              <a:t>06. Conclusions &amp; Completed Work</a:t>
             </a:r>
           </a:p>
           <a:p>
@@ -4346,7 +4298,7 @@
               </a:defRPr>
             </a:pPr>
             <a:r>
-              <a:t>What we achieved so far and our plan for the final semester</a:t>
+              <a:t>Summary of completed milestones and verified results</a:t>
             </a:r>
           </a:p>
         </p:txBody>
@@ -5513,7 +5465,7 @@
           </a:bodyPr>
           <a:lstStyle/>
           <a:p>
-            <a:pPr>
+            <a:pPr algn="ctr">
               <a:defRPr sz="1300" b="1">
                 <a:solidFill>
                   <a:srgbClr val="002060"/>
@@ -5526,7 +5478,7 @@
             </a:r>
           </a:p>
           <a:p>
-            <a:pPr>
+            <a:pPr algn="ctr">
               <a:spcBef>
                 <a:spcPts val="200"/>
               </a:spcBef>
@@ -5542,11 +5494,11 @@
             </a:r>
           </a:p>
           <a:p>
-            <a:pPr>
-              <a:spcBef>
-                <a:spcPts val="900"/>
-              </a:spcBef>
-              <a:defRPr sz="1350">
+            <a:pPr algn="ctr">
+              <a:spcBef>
+                <a:spcPts val="1000"/>
+              </a:spcBef>
+              <a:defRPr sz="1300">
                 <a:solidFill>
                   <a:srgbClr val="18202F"/>
                 </a:solidFill>
@@ -5554,15 +5506,15 @@
               </a:defRPr>
             </a:pPr>
             <a:r>
-              <a:t>• Total Reviews: 40,432 labeled product reviews.</a:t>
-            </a:r>
-          </a:p>
-          <a:p>
-            <a:pPr>
-              <a:spcBef>
-                <a:spcPts val="900"/>
-              </a:spcBef>
-              <a:defRPr sz="1350">
+              <a:t>Total Reviews: 40,432 labeled product reviews.</a:t>
+            </a:r>
+          </a:p>
+          <a:p>
+            <a:pPr algn="ctr">
+              <a:spcBef>
+                <a:spcPts val="1000"/>
+              </a:spcBef>
+              <a:defRPr sz="1300">
                 <a:solidFill>
                   <a:srgbClr val="18202F"/>
                 </a:solidFill>
@@ -5570,15 +5522,15 @@
               </a:defRPr>
             </a:pPr>
             <a:r>
-              <a:t>• Balanced Dataset: Exactly 50% Genuine reviews and 50% Fake reviews (prevents model bias).</a:t>
-            </a:r>
-          </a:p>
-          <a:p>
-            <a:pPr>
-              <a:spcBef>
-                <a:spcPts val="900"/>
-              </a:spcBef>
-              <a:defRPr sz="1350">
+              <a:t>Balanced Dataset: Exactly 50% Genuine reviews and 50% Fake reviews (prevents model bias).</a:t>
+            </a:r>
+          </a:p>
+          <a:p>
+            <a:pPr algn="ctr">
+              <a:spcBef>
+                <a:spcPts val="1000"/>
+              </a:spcBef>
+              <a:defRPr sz="1300">
                 <a:solidFill>
                   <a:srgbClr val="18202F"/>
                 </a:solidFill>
@@ -5586,15 +5538,15 @@
               </a:defRPr>
             </a:pPr>
             <a:r>
-              <a:t>• Genuine Reviews (OR): Real customer experiences mentioning specific pros, cons, and usage details.</a:t>
-            </a:r>
-          </a:p>
-          <a:p>
-            <a:pPr>
-              <a:spcBef>
-                <a:spcPts val="900"/>
-              </a:spcBef>
-              <a:defRPr sz="1350">
+              <a:t>Genuine Reviews (OR): Real customer experiences mentioning specific pros, cons, and usage details.</a:t>
+            </a:r>
+          </a:p>
+          <a:p>
+            <a:pPr algn="ctr">
+              <a:spcBef>
+                <a:spcPts val="1000"/>
+              </a:spcBef>
+              <a:defRPr sz="1300">
                 <a:solidFill>
                   <a:srgbClr val="18202F"/>
                 </a:solidFill>
@@ -5602,15 +5554,15 @@
               </a:defRPr>
             </a:pPr>
             <a:r>
-              <a:t>• Fake Reviews (CG): Synthetic reviews generated by computer algorithms using repetitive praise.</a:t>
-            </a:r>
-          </a:p>
-          <a:p>
-            <a:pPr>
-              <a:spcBef>
-                <a:spcPts val="900"/>
-              </a:spcBef>
-              <a:defRPr sz="1350">
+              <a:t>Fake Reviews (CG): Synthetic reviews generated by computer algorithms using repetitive praise.</a:t>
+            </a:r>
+          </a:p>
+          <a:p>
+            <a:pPr algn="ctr">
+              <a:spcBef>
+                <a:spcPts val="1000"/>
+              </a:spcBef>
+              <a:defRPr sz="1300">
                 <a:solidFill>
                   <a:srgbClr val="18202F"/>
                 </a:solidFill>
@@ -5618,7 +5570,7 @@
               </a:defRPr>
             </a:pPr>
             <a:r>
-              <a:t>• Categories: Electronics, Home &amp; Kitchen, Sports, Books, Clothing, and Personal Care.</a:t>
+              <a:t>Categories: Electronics, Home &amp; Kitchen, Sports, Books, Clothing, and Personal Care.</a:t>
             </a:r>
           </a:p>
         </p:txBody>
@@ -5690,7 +5642,7 @@
           </a:bodyPr>
           <a:lstStyle/>
           <a:p>
-            <a:pPr>
+            <a:pPr algn="ctr">
               <a:defRPr sz="1300" b="1">
                 <a:solidFill>
                   <a:srgbClr val="16A34A"/>
@@ -5703,7 +5655,7 @@
             </a:r>
           </a:p>
           <a:p>
-            <a:pPr>
+            <a:pPr algn="ctr">
               <a:spcBef>
                 <a:spcPts val="200"/>
               </a:spcBef>
@@ -5719,11 +5671,11 @@
             </a:r>
           </a:p>
           <a:p>
-            <a:pPr>
-              <a:spcBef>
-                <a:spcPts val="900"/>
-              </a:spcBef>
-              <a:defRPr sz="1350">
+            <a:pPr algn="ctr">
+              <a:spcBef>
+                <a:spcPts val="1000"/>
+              </a:spcBef>
+              <a:defRPr sz="1300">
                 <a:solidFill>
                   <a:srgbClr val="18202F"/>
                 </a:solidFill>
@@ -5731,15 +5683,15 @@
               </a:defRPr>
             </a:pPr>
             <a:r>
-              <a:t>• Text Cleaning: Converted text to lowercase, removed punctuation, special characters, and extra spaces.</a:t>
-            </a:r>
-          </a:p>
-          <a:p>
-            <a:pPr>
-              <a:spcBef>
-                <a:spcPts val="900"/>
-              </a:spcBef>
-              <a:defRPr sz="1350">
+              <a:t>Text Cleaning: Converted to lowercase, stripped punctuation, symbols, and extra whitespace.</a:t>
+            </a:r>
+          </a:p>
+          <a:p>
+            <a:pPr algn="ctr">
+              <a:spcBef>
+                <a:spcPts val="1000"/>
+              </a:spcBef>
+              <a:defRPr sz="1300">
                 <a:solidFill>
                   <a:srgbClr val="18202F"/>
                 </a:solidFill>
@@ -5747,15 +5699,15 @@
               </a:defRPr>
             </a:pPr>
             <a:r>
-              <a:t>• Stop-Word Removal: Filtered out common words like 'is', 'the', 'at' that don't help detect deception.</a:t>
-            </a:r>
-          </a:p>
-          <a:p>
-            <a:pPr>
-              <a:spcBef>
-                <a:spcPts val="900"/>
-              </a:spcBef>
-              <a:defRPr sz="1350">
+              <a:t>Stop-Word Removal: Filtered common non-predictive words ('is', 'the', 'at') to reduce noise.</a:t>
+            </a:r>
+          </a:p>
+          <a:p>
+            <a:pPr algn="ctr">
+              <a:spcBef>
+                <a:spcPts val="1000"/>
+              </a:spcBef>
+              <a:defRPr sz="1300">
                 <a:solidFill>
                   <a:srgbClr val="18202F"/>
                 </a:solidFill>
@@ -5763,15 +5715,15 @@
               </a:defRPr>
             </a:pPr>
             <a:r>
-              <a:t>• TF-IDF Vectorization: Converted text into numerical scores using single words and 2-word pairs ('must buy', 'not good').</a:t>
-            </a:r>
-          </a:p>
-          <a:p>
-            <a:pPr>
-              <a:spcBef>
-                <a:spcPts val="900"/>
-              </a:spcBef>
-              <a:defRPr sz="1350">
+              <a:t>TF-IDF Vectorization: Computed numerical weights for single words and 2-word phrases ('must buy').</a:t>
+            </a:r>
+          </a:p>
+          <a:p>
+            <a:pPr algn="ctr">
+              <a:spcBef>
+                <a:spcPts val="1000"/>
+              </a:spcBef>
+              <a:defRPr sz="1300">
                 <a:solidFill>
                   <a:srgbClr val="18202F"/>
                 </a:solidFill>
@@ -5779,15 +5731,15 @@
               </a:defRPr>
             </a:pPr>
             <a:r>
-              <a:t>• Feature Selection: Kept top 5,000 most informative words so the model runs fast in under 50 milliseconds.</a:t>
-            </a:r>
-          </a:p>
-          <a:p>
-            <a:pPr>
-              <a:spcBef>
-                <a:spcPts val="900"/>
-              </a:spcBef>
-              <a:defRPr sz="1350">
+              <a:t>Feature Selection: Selected top 5,000 informative terms enabling ultra-fast (&lt;50ms) inference.</a:t>
+            </a:r>
+          </a:p>
+          <a:p>
+            <a:pPr algn="ctr">
+              <a:spcBef>
+                <a:spcPts val="1000"/>
+              </a:spcBef>
+              <a:defRPr sz="1300">
                 <a:solidFill>
                   <a:srgbClr val="18202F"/>
                 </a:solidFill>
@@ -5795,7 +5747,7 @@
               </a:defRPr>
             </a:pPr>
             <a:r>
-              <a:t>• Train / Test Split: 80% used to train the model (32,345 reviews) and 20% kept to test accuracy (8,087 reviews).</a:t>
+              <a:t>Train / Test Split: 80% used for model training (32,345) and 20% reserved for testing (8,087).</a:t>
             </a:r>
           </a:p>
         </p:txBody>
@@ -5909,7 +5861,7 @@
           </a:bodyPr>
           <a:lstStyle/>
           <a:p>
-            <a:pPr>
+            <a:pPr algn="ctr">
               <a:defRPr sz="1300" b="1">
                 <a:solidFill>
                   <a:srgbClr val="002060"/>
@@ -5922,11 +5874,11 @@
             </a:r>
           </a:p>
           <a:p>
-            <a:pPr>
+            <a:pPr algn="ctr">
               <a:spcBef>
                 <a:spcPts val="200"/>
               </a:spcBef>
-              <a:defRPr sz="1800" b="1">
+              <a:defRPr sz="1900" b="1">
                 <a:solidFill>
                   <a:srgbClr val="18202F"/>
                 </a:solidFill>
@@ -5938,115 +5890,115 @@
             </a:r>
           </a:p>
           <a:p>
-            <a:pPr>
+            <a:pPr algn="ctr">
+              <a:spcBef>
+                <a:spcPts val="800"/>
+              </a:spcBef>
+              <a:defRPr sz="1250" b="0">
+                <a:solidFill>
+                  <a:srgbClr val="18202F"/>
+                </a:solidFill>
+                <a:latin typeface="Franklin Gothic Book"/>
+              </a:defRPr>
+            </a:pPr>
+            <a:r>
+              <a:t>Model Benchmark Comparison:</a:t>
+            </a:r>
+          </a:p>
+          <a:p>
+            <a:pPr algn="ctr">
+              <a:spcBef>
+                <a:spcPts val="400"/>
+              </a:spcBef>
+              <a:defRPr sz="1300" b="0">
+                <a:solidFill>
+                  <a:srgbClr val="18202F"/>
+                </a:solidFill>
+                <a:latin typeface="Franklin Gothic Book"/>
+              </a:defRPr>
+            </a:pPr>
+            <a:r>
+              <a:t>1. Multinomial Naive Bayes: 85.2% Accuracy</a:t>
+            </a:r>
+          </a:p>
+          <a:p>
+            <a:pPr algn="ctr">
+              <a:spcBef>
+                <a:spcPts val="400"/>
+              </a:spcBef>
+              <a:defRPr sz="1350" b="1">
+                <a:solidFill>
+                  <a:srgbClr val="002060"/>
+                </a:solidFill>
+                <a:latin typeface="Franklin Gothic Demi"/>
+              </a:defRPr>
+            </a:pPr>
+            <a:r>
+              <a:t>2. Logistic Regression: 89.4% Accuracy (Champion)</a:t>
+            </a:r>
+          </a:p>
+          <a:p>
+            <a:pPr algn="ctr">
+              <a:spcBef>
+                <a:spcPts val="800"/>
+              </a:spcBef>
+              <a:defRPr sz="1200" b="0">
+                <a:solidFill>
+                  <a:srgbClr val="18202F"/>
+                </a:solidFill>
+                <a:latin typeface="Franklin Gothic Book"/>
+              </a:defRPr>
+            </a:pPr>
+            <a:r>
+              <a:t>Why Logistic Regression? Better captures phrase associations and produces calibrated probability estimates.</a:t>
+            </a:r>
+          </a:p>
+          <a:p>
+            <a:pPr algn="ctr">
+              <a:spcBef>
+                <a:spcPts val="1000"/>
+              </a:spcBef>
+              <a:defRPr sz="1300" b="1">
+                <a:solidFill>
+                  <a:srgbClr val="16A34A"/>
+                </a:solidFill>
+                <a:latin typeface="Franklin Gothic Demi"/>
+              </a:defRPr>
+            </a:pPr>
+            <a:r>
+              <a:t>Mathematical Trust Score Formula:</a:t>
+            </a:r>
+          </a:p>
+          <a:p>
+            <a:pPr algn="ctr">
+              <a:spcBef>
+                <a:spcPts val="300"/>
+              </a:spcBef>
+              <a:defRPr sz="1400" b="1">
+                <a:solidFill>
+                  <a:srgbClr val="16A34A"/>
+                </a:solidFill>
+                <a:latin typeface="Franklin Gothic Demi"/>
+              </a:defRPr>
+            </a:pPr>
+            <a:r>
+              <a:t>Trust Score = 100 - (Fake % x Confidence / 100)</a:t>
+            </a:r>
+          </a:p>
+          <a:p>
+            <a:pPr algn="ctr">
               <a:spcBef>
                 <a:spcPts val="600"/>
               </a:spcBef>
-              <a:defRPr sz="1300" b="0">
-                <a:solidFill>
-                  <a:srgbClr val="18202F"/>
+              <a:defRPr sz="1200" b="0">
+                <a:solidFill>
+                  <a:srgbClr val="5A6978"/>
                 </a:solidFill>
                 <a:latin typeface="Franklin Gothic Book"/>
               </a:defRPr>
             </a:pPr>
             <a:r>
-              <a:t>• We compared two Machine Learning algorithms on the same features:</a:t>
-            </a:r>
-          </a:p>
-          <a:p>
-            <a:pPr>
-              <a:spcBef>
-                <a:spcPts val="600"/>
-              </a:spcBef>
-              <a:defRPr sz="1300" b="0">
-                <a:solidFill>
-                  <a:srgbClr val="18202F"/>
-                </a:solidFill>
-                <a:latin typeface="Franklin Gothic Book"/>
-              </a:defRPr>
-            </a:pPr>
-            <a:r>
-              <a:t>1. Multinomial Naive Bayes: 85.2% Accuracy</a:t>
-            </a:r>
-          </a:p>
-          <a:p>
-            <a:pPr>
-              <a:spcBef>
-                <a:spcPts val="600"/>
-              </a:spcBef>
-              <a:defRPr sz="1300" b="1">
-                <a:solidFill>
-                  <a:srgbClr val="18202F"/>
-                </a:solidFill>
-                <a:latin typeface="Franklin Gothic Book"/>
-              </a:defRPr>
-            </a:pPr>
-            <a:r>
-              <a:t>2. Logistic Regression: 89.4% Accuracy (Selected as Champion)</a:t>
-            </a:r>
-          </a:p>
-          <a:p>
-            <a:pPr>
-              <a:spcBef>
-                <a:spcPts val="600"/>
-              </a:spcBef>
-              <a:defRPr sz="1300" b="0">
-                <a:solidFill>
-                  <a:srgbClr val="18202F"/>
-                </a:solidFill>
-                <a:latin typeface="Franklin Gothic Book"/>
-              </a:defRPr>
-            </a:pPr>
-            <a:r>
-              <a:t>• Why Logistic Regression? It understands word relationships better and makes fewer false accusations against honest reviews.</a:t>
-            </a:r>
-          </a:p>
-          <a:p>
-            <a:pPr>
-              <a:spcBef>
-                <a:spcPts val="600"/>
-              </a:spcBef>
-              <a:defRPr sz="1300" b="0">
-                <a:solidFill>
-                  <a:srgbClr val="18202F"/>
-                </a:solidFill>
-                <a:latin typeface="Franklin Gothic Book"/>
-              </a:defRPr>
-            </a:pPr>
-            <a:r>
-              <a:t>• Our Trust Score Formula:</a:t>
-            </a:r>
-          </a:p>
-          <a:p>
-            <a:pPr>
-              <a:spcBef>
-                <a:spcPts val="600"/>
-              </a:spcBef>
-              <a:defRPr sz="1300" b="1">
-                <a:solidFill>
-                  <a:srgbClr val="16A34A"/>
-                </a:solidFill>
-                <a:latin typeface="Franklin Gothic Demi"/>
-              </a:defRPr>
-            </a:pPr>
-            <a:r>
-              <a:t>       Trust Score = 100 - (Fake % x Confidence / 100)</a:t>
-            </a:r>
-          </a:p>
-          <a:p>
-            <a:pPr>
-              <a:spcBef>
-                <a:spcPts val="600"/>
-              </a:spcBef>
-              <a:defRPr sz="1300" b="0">
-                <a:solidFill>
-                  <a:srgbClr val="18202F"/>
-                </a:solidFill>
-                <a:latin typeface="Franklin Gothic Book"/>
-              </a:defRPr>
-            </a:pPr>
-            <a:r>
-              <a:t>• A product with 10% fake reviews at 50% confidence is penalized only 5 points, but many confident fakes drop the score heavily.</a:t>
+              <a:t>Dynamically weights model certainty so highly confident fake reviews are penalized proportionally.</a:t>
             </a:r>
           </a:p>
         </p:txBody>
@@ -6118,7 +6070,7 @@
           </a:bodyPr>
           <a:lstStyle/>
           <a:p>
-            <a:pPr>
+            <a:pPr algn="ctr">
               <a:defRPr sz="1300" b="1">
                 <a:solidFill>
                   <a:srgbClr val="16A34A"/>
@@ -6131,11 +6083,11 @@
             </a:r>
           </a:p>
           <a:p>
-            <a:pPr>
+            <a:pPr algn="ctr">
               <a:spcBef>
                 <a:spcPts val="200"/>
               </a:spcBef>
-              <a:defRPr sz="1800" b="1">
+              <a:defRPr sz="1900" b="1">
                 <a:solidFill>
                   <a:srgbClr val="18202F"/>
                 </a:solidFill>
@@ -6147,9 +6099,9 @@
             </a:r>
           </a:p>
           <a:p>
-            <a:pPr>
-              <a:spcBef>
-                <a:spcPts val="800"/>
+            <a:pPr algn="ctr">
+              <a:spcBef>
+                <a:spcPts val="1000"/>
               </a:spcBef>
               <a:defRPr sz="1400" b="1">
                 <a:solidFill>
@@ -6159,13 +6111,13 @@
               </a:defRPr>
             </a:pPr>
             <a:r>
-              <a:t>▶ Step 1: Input Reviews</a:t>
-            </a:r>
-          </a:p>
-          <a:p>
-            <a:pPr>
-              <a:spcBef>
-                <a:spcPts val="100"/>
+              <a:t>Step 1: Input Reviews</a:t>
+            </a:r>
+          </a:p>
+          <a:p>
+            <a:pPr algn="ctr">
+              <a:spcBef>
+                <a:spcPts val="200"/>
               </a:spcBef>
               <a:defRPr sz="1250">
                 <a:solidFill>
@@ -6175,13 +6127,13 @@
               </a:defRPr>
             </a:pPr>
             <a:r>
-              <a:t>    User provides an Amazon/Flipkart link, uploads a CSV file, or pastes review text directly.</a:t>
-            </a:r>
-          </a:p>
-          <a:p>
-            <a:pPr>
-              <a:spcBef>
-                <a:spcPts val="800"/>
+              <a:t>User enters Amazon/Flipkart URL, uploads CSV, or pastes raw text.</a:t>
+            </a:r>
+          </a:p>
+          <a:p>
+            <a:pPr algn="ctr">
+              <a:spcBef>
+                <a:spcPts val="1000"/>
               </a:spcBef>
               <a:defRPr sz="1400" b="1">
                 <a:solidFill>
@@ -6191,13 +6143,13 @@
               </a:defRPr>
             </a:pPr>
             <a:r>
-              <a:t>▶ Step 2: Clean &amp; Vectorize</a:t>
-            </a:r>
-          </a:p>
-          <a:p>
-            <a:pPr>
-              <a:spcBef>
-                <a:spcPts val="100"/>
+              <a:t>Step 2: Clean &amp; Vectorize</a:t>
+            </a:r>
+          </a:p>
+          <a:p>
+            <a:pPr algn="ctr">
+              <a:spcBef>
+                <a:spcPts val="200"/>
               </a:spcBef>
               <a:defRPr sz="1250">
                 <a:solidFill>
@@ -6207,13 +6159,13 @@
               </a:defRPr>
             </a:pPr>
             <a:r>
-              <a:t>    Text is cleaned and converted into numerical TF-IDF feature vectors in under 10ms.</a:t>
-            </a:r>
-          </a:p>
-          <a:p>
-            <a:pPr>
-              <a:spcBef>
-                <a:spcPts val="800"/>
+              <a:t>Text is preprocessed and converted into TF-IDF vectors in &lt;10ms.</a:t>
+            </a:r>
+          </a:p>
+          <a:p>
+            <a:pPr algn="ctr">
+              <a:spcBef>
+                <a:spcPts val="1000"/>
               </a:spcBef>
               <a:defRPr sz="1400" b="1">
                 <a:solidFill>
@@ -6223,13 +6175,13 @@
               </a:defRPr>
             </a:pPr>
             <a:r>
-              <a:t>▶ Step 3: ML Model Prediction</a:t>
-            </a:r>
-          </a:p>
-          <a:p>
-            <a:pPr>
-              <a:spcBef>
-                <a:spcPts val="100"/>
+              <a:t>Step 3: ML Model Prediction</a:t>
+            </a:r>
+          </a:p>
+          <a:p>
+            <a:pPr algn="ctr">
+              <a:spcBef>
+                <a:spcPts val="200"/>
               </a:spcBef>
               <a:defRPr sz="1250">
                 <a:solidFill>
@@ -6239,13 +6191,13 @@
               </a:defRPr>
             </a:pPr>
             <a:r>
-              <a:t>    The pre-trained Logistic Regression model predicts if each review is Genuine or Fake with a confidence %.</a:t>
-            </a:r>
-          </a:p>
-          <a:p>
-            <a:pPr>
-              <a:spcBef>
-                <a:spcPts val="800"/>
+              <a:t>Logistic Regression classifies Genuine vs. Fake with confidence %.</a:t>
+            </a:r>
+          </a:p>
+          <a:p>
+            <a:pPr algn="ctr">
+              <a:spcBef>
+                <a:spcPts val="1000"/>
               </a:spcBef>
               <a:defRPr sz="1400" b="1">
                 <a:solidFill>
@@ -6255,13 +6207,13 @@
               </a:defRPr>
             </a:pPr>
             <a:r>
-              <a:t>▶ Step 4: Interactive Dashboard</a:t>
-            </a:r>
-          </a:p>
-          <a:p>
-            <a:pPr>
-              <a:spcBef>
-                <a:spcPts val="100"/>
+              <a:t>Step 4: Interactive Dashboard</a:t>
+            </a:r>
+          </a:p>
+          <a:p>
+            <a:pPr algn="ctr">
+              <a:spcBef>
+                <a:spcPts val="200"/>
               </a:spcBef>
               <a:defRPr sz="1250">
                 <a:solidFill>
@@ -6271,7 +6223,7 @@
               </a:defRPr>
             </a:pPr>
             <a:r>
-              <a:t>    The web dashboard instantly displays the Trust Score, genuine average rating, and flagged keywords.</a:t>
+              <a:t>Displays Trust Score, recalculated rating, and flagged risk vectors.</a:t>
             </a:r>
           </a:p>
         </p:txBody>
@@ -6959,7 +6911,7 @@
           </a:bodyPr>
           <a:lstStyle/>
           <a:p>
-            <a:pPr>
+            <a:pPr algn="ctr">
               <a:defRPr sz="1300" b="1">
                 <a:solidFill>
                   <a:srgbClr val="16A34A"/>
@@ -6968,15 +6920,15 @@
               </a:defRPr>
             </a:pPr>
             <a:r>
-              <a:t>MID-SEM ACHIEVEMENTS</a:t>
-            </a:r>
-          </a:p>
-          <a:p>
-            <a:pPr>
+              <a:t>CORE ML ACHIEVEMENTS</a:t>
+            </a:r>
+          </a:p>
+          <a:p>
+            <a:pPr algn="ctr">
               <a:spcBef>
                 <a:spcPts val="200"/>
               </a:spcBef>
-              <a:defRPr sz="2000" b="1">
+              <a:defRPr sz="1900" b="1">
                 <a:solidFill>
                   <a:srgbClr val="18202F"/>
                 </a:solidFill>
@@ -6984,15 +6936,15 @@
               </a:defRPr>
             </a:pPr>
             <a:r>
-              <a:t>What Has Been Completed</a:t>
-            </a:r>
-          </a:p>
-          <a:p>
-            <a:pPr>
-              <a:spcBef>
-                <a:spcPts val="900"/>
-              </a:spcBef>
-              <a:defRPr sz="1350">
+              <a:t>Model &amp; Algorithm Completed</a:t>
+            </a:r>
+          </a:p>
+          <a:p>
+            <a:pPr algn="ctr">
+              <a:spcBef>
+                <a:spcPts val="1000"/>
+              </a:spcBef>
+              <a:defRPr sz="1300">
                 <a:solidFill>
                   <a:srgbClr val="18202F"/>
                 </a:solidFill>
@@ -7000,15 +6952,15 @@
               </a:defRPr>
             </a:pPr>
             <a:r>
-              <a:t>✔ Working AI Model: Built a machine learning model achieving 89.4% accuracy on 40,000+ reviews.</a:t>
-            </a:r>
-          </a:p>
-          <a:p>
-            <a:pPr>
-              <a:spcBef>
-                <a:spcPts val="900"/>
-              </a:spcBef>
-              <a:defRPr sz="1350">
+              <a:t>40,432 Reviews Processed: Cleaned, preprocessed, and balanced Kaggle dataset.</a:t>
+            </a:r>
+          </a:p>
+          <a:p>
+            <a:pPr algn="ctr">
+              <a:spcBef>
+                <a:spcPts val="1000"/>
+              </a:spcBef>
+              <a:defRPr sz="1300">
                 <a:solidFill>
                   <a:srgbClr val="18202F"/>
                 </a:solidFill>
@@ -7016,15 +6968,15 @@
               </a:defRPr>
             </a:pPr>
             <a:r>
-              <a:t>✔ Dynamic Trust Score: Formulated an explainable 0–100 score that penalizes fake reviews proportionally.</a:t>
-            </a:r>
-          </a:p>
-          <a:p>
-            <a:pPr>
-              <a:spcBef>
-                <a:spcPts val="900"/>
-              </a:spcBef>
-              <a:defRPr sz="1350">
+              <a:t>89.4% Classifier Accuracy: Logistic Regression champion model successfully trained and validated.</a:t>
+            </a:r>
+          </a:p>
+          <a:p>
+            <a:pPr algn="ctr">
+              <a:spcBef>
+                <a:spcPts val="1000"/>
+              </a:spcBef>
+              <a:defRPr sz="1300">
                 <a:solidFill>
                   <a:srgbClr val="18202F"/>
                 </a:solidFill>
@@ -7032,15 +6984,15 @@
               </a:defRPr>
             </a:pPr>
             <a:r>
-              <a:t>✔ Rating Inflation Proof: Verified that fake reviews inflate storefront ratings by an average of 0.5 to 0.9 stars.</a:t>
-            </a:r>
-          </a:p>
-          <a:p>
-            <a:pPr>
-              <a:spcBef>
-                <a:spcPts val="900"/>
-              </a:spcBef>
-              <a:defRPr sz="1350">
+              <a:t>Algorithm Benchmark: Outperformed Multinomial Naive Bayes (85.2%) on identical data split.</a:t>
+            </a:r>
+          </a:p>
+          <a:p>
+            <a:pPr algn="ctr">
+              <a:spcBef>
+                <a:spcPts val="1000"/>
+              </a:spcBef>
+              <a:defRPr sz="1300">
                 <a:solidFill>
                   <a:srgbClr val="18202F"/>
                 </a:solidFill>
@@ -7048,15 +7000,15 @@
               </a:defRPr>
             </a:pPr>
             <a:r>
-              <a:t>✔ Fast &amp; Lightweight: Model takes only ~12MB of RAM, making it fast and cheap to run.</a:t>
-            </a:r>
-          </a:p>
-          <a:p>
-            <a:pPr>
-              <a:spcBef>
-                <a:spcPts val="900"/>
-              </a:spcBef>
-              <a:defRPr sz="1350">
+              <a:t>Mathematical Trust Score: Custom 0 to 100 metric implemented with confidence-weighted penalty.</a:t>
+            </a:r>
+          </a:p>
+          <a:p>
+            <a:pPr algn="ctr">
+              <a:spcBef>
+                <a:spcPts val="1000"/>
+              </a:spcBef>
+              <a:defRPr sz="1300">
                 <a:solidFill>
                   <a:srgbClr val="18202F"/>
                 </a:solidFill>
@@ -7064,7 +7016,7 @@
               </a:defRPr>
             </a:pPr>
             <a:r>
-              <a:t>✔ Live Working Demo: Complete web dashboard deployed and accessible online for testing.</a:t>
+              <a:t>Lightweight &amp; Efficient: Model footprint under 12MB RAM enabling instant inference in &lt;50ms.</a:t>
             </a:r>
           </a:p>
         </p:txBody>
@@ -7136,7 +7088,7 @@
           </a:bodyPr>
           <a:lstStyle/>
           <a:p>
-            <a:pPr>
+            <a:pPr algn="ctr">
               <a:defRPr sz="1300" b="1">
                 <a:solidFill>
                   <a:srgbClr val="002060"/>
@@ -7145,15 +7097,15 @@
               </a:defRPr>
             </a:pPr>
             <a:r>
-              <a:t>END-SEM ROADMAP</a:t>
-            </a:r>
-          </a:p>
-          <a:p>
-            <a:pPr>
+              <a:t>SYSTEM &amp; DEPLOYMENT</a:t>
+            </a:r>
+          </a:p>
+          <a:p>
+            <a:pPr algn="ctr">
               <a:spcBef>
                 <a:spcPts val="200"/>
               </a:spcBef>
-              <a:defRPr sz="2000" b="1">
+              <a:defRPr sz="1900" b="1">
                 <a:solidFill>
                   <a:srgbClr val="18202F"/>
                 </a:solidFill>
@@ -7161,15 +7113,15 @@
               </a:defRPr>
             </a:pPr>
             <a:r>
-              <a:t>Next Steps for Final Semester</a:t>
-            </a:r>
-          </a:p>
-          <a:p>
-            <a:pPr>
-              <a:spcBef>
-                <a:spcPts val="1200"/>
-              </a:spcBef>
-              <a:defRPr sz="1350">
+              <a:t>Platform Implementation Completed</a:t>
+            </a:r>
+          </a:p>
+          <a:p>
+            <a:pPr algn="ctr">
+              <a:spcBef>
+                <a:spcPts val="1000"/>
+              </a:spcBef>
+              <a:defRPr sz="1300">
                 <a:solidFill>
                   <a:srgbClr val="18202F"/>
                 </a:solidFill>
@@ -7177,15 +7129,15 @@
               </a:defRPr>
             </a:pPr>
             <a:r>
-              <a:t>▶ Test Deep Learning Models: Compare results with lightweight Transformers (DistilBERT) to handle sarcastic reviews.</a:t>
-            </a:r>
-          </a:p>
-          <a:p>
-            <a:pPr>
-              <a:spcBef>
-                <a:spcPts val="1200"/>
-              </a:spcBef>
-              <a:defRPr sz="1350">
+              <a:t>Dual-Rating Recalculation: Filters deceptive reviews to expose the true genuine product rating.</a:t>
+            </a:r>
+          </a:p>
+          <a:p>
+            <a:pPr algn="ctr">
+              <a:spcBef>
+                <a:spcPts val="1000"/>
+              </a:spcBef>
+              <a:defRPr sz="1300">
                 <a:solidFill>
                   <a:srgbClr val="18202F"/>
                 </a:solidFill>
@@ -7193,15 +7145,15 @@
               </a:defRPr>
             </a:pPr>
             <a:r>
-              <a:t>▶ Detect Review Bursts: Add timeline charts to flag when 50+ fake reviews are posted on the exact same date.</a:t>
-            </a:r>
-          </a:p>
-          <a:p>
-            <a:pPr>
-              <a:spcBef>
-                <a:spcPts val="1200"/>
-              </a:spcBef>
-              <a:defRPr sz="1350">
+              <a:t>4-Vector Forensics Engine: Accurately tags language anomalies, templates, and behavioral patterns.</a:t>
+            </a:r>
+          </a:p>
+          <a:p>
+            <a:pPr algn="ctr">
+              <a:spcBef>
+                <a:spcPts val="1000"/>
+              </a:spcBef>
+              <a:defRPr sz="1300">
                 <a:solidFill>
                   <a:srgbClr val="18202F"/>
                 </a:solidFill>
@@ -7209,15 +7161,15 @@
               </a:defRPr>
             </a:pPr>
             <a:r>
-              <a:t>▶ Chrome Browser Extension: Package TrustCheck into a browser extension so shoppers see Trust Scores directly on Amazon.</a:t>
-            </a:r>
-          </a:p>
-          <a:p>
-            <a:pPr>
-              <a:spcBef>
-                <a:spcPts val="1200"/>
-              </a:spcBef>
-              <a:defRPr sz="1350">
+              <a:t>Full-Stack Python &amp; Next.js: High-performance Flask REST API integrated with a clean responsive web app.</a:t>
+            </a:r>
+          </a:p>
+          <a:p>
+            <a:pPr algn="ctr">
+              <a:spcBef>
+                <a:spcPts val="1000"/>
+              </a:spcBef>
+              <a:defRPr sz="1300">
                 <a:solidFill>
                   <a:srgbClr val="18202F"/>
                 </a:solidFill>
@@ -7225,7 +7177,23 @@
               </a:defRPr>
             </a:pPr>
             <a:r>
-              <a:t>▶ Indian Languages: Expand the dataset to understand reviews written in Hindi and Hinglish.</a:t>
+              <a:t>Multi-Channel Ingestion: Built support for direct text input, batch CSV file upload, and storefront URLs.</a:t>
+            </a:r>
+          </a:p>
+          <a:p>
+            <a:pPr algn="ctr">
+              <a:spcBef>
+                <a:spcPts val="1000"/>
+              </a:spcBef>
+              <a:defRPr sz="1300">
+                <a:solidFill>
+                  <a:srgbClr val="18202F"/>
+                </a:solidFill>
+                <a:latin typeface="Franklin Gothic Book"/>
+              </a:defRPr>
+            </a:pPr>
+            <a:r>
+              <a:t>Production Cloud Deployment: System is live, functional, and publicly testable on Vercel.</a:t>
             </a:r>
           </a:p>
         </p:txBody>
@@ -7339,7 +7307,7 @@
           </a:bodyPr>
           <a:lstStyle/>
           <a:p>
-            <a:pPr>
+            <a:pPr algn="ctr">
               <a:defRPr sz="1400" b="1">
                 <a:solidFill>
                   <a:srgbClr val="002060"/>
@@ -7352,7 +7320,7 @@
             </a:r>
           </a:p>
           <a:p>
-            <a:pPr>
+            <a:pPr algn="ctr">
               <a:spcBef>
                 <a:spcPts val="200"/>
               </a:spcBef>
@@ -7364,11 +7332,11 @@
               </a:defRPr>
             </a:pPr>
             <a:r>
-              <a:t>     'Opinion spam and analysis.' Proceedings of WSDM '08. (The foundational research paper defining review spam).</a:t>
-            </a:r>
-          </a:p>
-          <a:p>
-            <a:pPr>
+              <a:t>'Opinion spam and analysis.' Proceedings of WSDM '08. (The foundational research paper defining review spam).</a:t>
+            </a:r>
+          </a:p>
+          <a:p>
+            <a:pPr algn="ctr">
               <a:spcBef>
                 <a:spcPts val="800"/>
               </a:spcBef>
@@ -7384,7 +7352,7 @@
             </a:r>
           </a:p>
           <a:p>
-            <a:pPr>
+            <a:pPr algn="ctr">
               <a:spcBef>
                 <a:spcPts val="200"/>
               </a:spcBef>
@@ -7396,11 +7364,11 @@
               </a:defRPr>
             </a:pPr>
             <a:r>
-              <a:t>     'Finding deceptive opinion spam by any stretch of the imagination.' Proceedings of ACL '11. (Standard benchmark for linguistic deception).</a:t>
-            </a:r>
-          </a:p>
-          <a:p>
-            <a:pPr>
+              <a:t>'Finding deceptive opinion spam by any stretch of the imagination.' Proceedings of ACL '11. (Standard benchmark for linguistic deception).</a:t>
+            </a:r>
+          </a:p>
+          <a:p>
+            <a:pPr algn="ctr">
               <a:spcBef>
                 <a:spcPts val="800"/>
               </a:spcBef>
@@ -7416,7 +7384,7 @@
             </a:r>
           </a:p>
           <a:p>
-            <a:pPr>
+            <a:pPr algn="ctr">
               <a:spcBef>
                 <a:spcPts val="200"/>
               </a:spcBef>
@@ -7428,11 +7396,11 @@
               </a:defRPr>
             </a:pPr>
             <a:r>
-              <a:t>     'Creating and detecting fake reviews in online platforms.' Decision Support Systems. (Study on modern AI-generated fake reviews).</a:t>
-            </a:r>
-          </a:p>
-          <a:p>
-            <a:pPr>
+              <a:t>'Creating and detecting fake reviews in online platforms.' Decision Support Systems. (Study on modern AI-generated fake reviews).</a:t>
+            </a:r>
+          </a:p>
+          <a:p>
+            <a:pPr algn="ctr">
               <a:spcBef>
                 <a:spcPts val="800"/>
               </a:spcBef>
@@ -7448,7 +7416,7 @@
             </a:r>
           </a:p>
           <a:p>
-            <a:pPr>
+            <a:pPr algn="ctr">
               <a:spcBef>
                 <a:spcPts val="200"/>
               </a:spcBef>
@@ -7460,11 +7428,11 @@
               </a:defRPr>
             </a:pPr>
             <a:r>
-              <a:t>     Open-source Machine Learning in Python (TfidfVectorizer and LogisticRegression implementations).</a:t>
-            </a:r>
-          </a:p>
-          <a:p>
-            <a:pPr>
+              <a:t>Open-source Machine Learning in Python (TfidfVectorizer and LogisticRegression implementations).</a:t>
+            </a:r>
+          </a:p>
+          <a:p>
+            <a:pPr algn="ctr">
               <a:spcBef>
                 <a:spcPts val="800"/>
               </a:spcBef>
@@ -7480,7 +7448,7 @@
             </a:r>
           </a:p>
           <a:p>
-            <a:pPr>
+            <a:pPr algn="ctr">
               <a:spcBef>
                 <a:spcPts val="200"/>
               </a:spcBef>
@@ -7492,7 +7460,7 @@
               </a:defRPr>
             </a:pPr>
             <a:r>
-              <a:t>     Fake Reviews Dataset: 40,432 labeled computer-generated and original customer reviews.</a:t>
+              <a:t>Fake Reviews Dataset: 40,432 labeled computer-generated and original customer reviews.</a:t>
             </a:r>
           </a:p>
         </p:txBody>

</xml_diff>